<commit_message>
Sprint 4 template: add rotation-log slide (color-coded per sprint), dashboard URL on cover, attendance line on R1 slide (260929_1422)
</commit_message>
<xml_diff>
--- a/assets/sprint4-presentation-template.pptx
+++ b/assets/sprint4-presentation-template.pptx
@@ -6,6 +6,7 @@
   </p:sldMasterIdLst>
   <p:sldIdLst>
     <p:sldId id="256" r:id="rId2"/>
+    <p:sldId id="264" r:id="rId15"/>
     <p:sldId id="257" r:id="rId3"/>
     <p:sldId id="258" r:id="rId4"/>
     <p:sldId id="259" r:id="rId5"/>
@@ -1645,7 +1646,45 @@
               </a:defRPr>
             </a:pPr>
             <a:r>
+              <a:rPr>
+                <a:solidFill/>
+              </a:rPr>
               <a:t>Prediction Challenge: S&amp;P 500 · Nasdaq-100 · Gold futures (/GC) — locked Wed 23:59 · scored Sat AM SGT · defended Monday (oral)</a:t>
+            </a:r>
+          </a:p>
+        </p:txBody>
+      </p:sp>
+      <p:sp>
+        <p:nvSpPr>
+          <p:cNvPr id="6" name="TextBox 5"/>
+          <p:cNvSpPr txBox="1"/>
+          <p:nvPr/>
+        </p:nvSpPr>
+        <p:spPr>
+          <a:xfrm>
+            <a:off x="731520" y="4157640"/>
+            <a:ext cx="10698480" cy="548640"/>
+          </a:xfrm>
+          <a:prstGeom prst="rect">
+            <a:avLst/>
+          </a:prstGeom>
+          <a:noFill/>
+        </p:spPr>
+        <p:txBody>
+          <a:bodyPr wrap="square">
+            <a:spAutoFit/>
+          </a:bodyPr>
+          <a:lstStyle/>
+          <a:p>
+            <a:pPr/>
+            <a:r>
+              <a:rPr sz="2000" b="0">
+                <a:solidFill>
+                  <a:srgbClr val="12C7B7"/>
+                </a:solidFill>
+                <a:latin typeface="Arial"/>
+              </a:rPr>
+              <a:t>Dashboard: [your team’s ui/index.html link]</a:t>
             </a:r>
           </a:p>
         </p:txBody>
@@ -1659,6 +1698,1939 @@
 </file>
 
 <file path=ppt/slides/slide2.xml><?xml version="1.0" encoding="utf-8"?>
+<p:sld xmlns:a="http://schemas.openxmlformats.org/drawingml/2006/main" xmlns:r="http://schemas.openxmlformats.org/officeDocument/2006/relationships" xmlns:p="http://schemas.openxmlformats.org/presentationml/2006/main">
+  <p:cSld name="Slide 5">
+    <p:bg>
+      <p:bgPr>
+        <a:solidFill>
+          <a:srgbClr val="F5F7FB"/>
+        </a:solidFill>
+      </p:bgPr>
+    </p:bg>
+    <p:spTree>
+      <p:nvGrpSpPr>
+        <p:cNvPr id="1" name=""/>
+        <p:cNvGrpSpPr/>
+        <p:nvPr/>
+      </p:nvGrpSpPr>
+      <p:grpSpPr>
+        <a:xfrm>
+          <a:off x="0" y="0"/>
+          <a:ext cx="0" cy="0"/>
+          <a:chOff x="0" y="0"/>
+          <a:chExt cx="0" cy="0"/>
+        </a:xfrm>
+      </p:grpSpPr>
+      <p:sp>
+        <p:nvSpPr>
+          <p:cNvPr id="2" name="Text 0"/>
+          <p:cNvSpPr txBox="1"/>
+          <p:nvPr/>
+        </p:nvSpPr>
+        <p:spPr>
+          <a:xfrm>
+            <a:off x="548640" y="365760"/>
+            <a:ext cx="10972800" cy="320040"/>
+          </a:xfrm>
+          <a:prstGeom prst="rect">
+            <a:avLst/>
+          </a:prstGeom>
+          <a:noFill/>
+          <a:ln/>
+        </p:spPr>
+        <p:txBody>
+          <a:bodyPr wrap="square" rtlCol="0" anchor="ctr"/>
+          <a:lstStyle/>
+          <a:p>
+            <a:pPr indent="0" marL="0">
+              <a:buNone/>
+            </a:pPr>
+            <a:r>
+              <a:rPr lang="en-US" sz="1100" b="1" spc="200" kern="0" dirty="0">
+                <a:solidFill>
+                  <a:srgbClr val="12C7B7"/>
+                </a:solidFill>
+                <a:latin typeface="Arial" pitchFamily="34" charset="0"/>
+                <a:ea typeface="Arial" pitchFamily="34" charset="-122"/>
+                <a:cs typeface="Arial" pitchFamily="34" charset="-120"/>
+              </a:rPr>
+              <a:t>TEAM ROTATION LOG</a:t>
+            </a:r>
+            <a:endParaRPr lang="en-US" sz="1100" dirty="0"/>
+          </a:p>
+        </p:txBody>
+      </p:sp>
+      <p:sp>
+        <p:nvSpPr>
+          <p:cNvPr id="3" name="Text 1"/>
+          <p:cNvSpPr txBox="1"/>
+          <p:nvPr/>
+        </p:nvSpPr>
+        <p:spPr>
+          <a:xfrm>
+            <a:off x="548640" y="658368"/>
+            <a:ext cx="10972800" cy="640080"/>
+          </a:xfrm>
+          <a:prstGeom prst="rect">
+            <a:avLst/>
+          </a:prstGeom>
+          <a:noFill/>
+          <a:ln/>
+        </p:spPr>
+        <p:txBody>
+          <a:bodyPr wrap="square" rtlCol="0" anchor="ctr"/>
+          <a:lstStyle/>
+          <a:p>
+            <a:pPr indent="0" marL="0">
+              <a:buNone/>
+            </a:pPr>
+            <a:r>
+              <a:rPr lang="en-US" sz="2600" b="1" dirty="0">
+                <a:solidFill>
+                  <a:srgbClr val="0E2A52"/>
+                </a:solidFill>
+                <a:latin typeface="Arial" pitchFamily="34" charset="0"/>
+                <a:ea typeface="Arial" pitchFamily="34" charset="-122"/>
+                <a:cs typeface="Arial" pitchFamily="34" charset="-120"/>
+              </a:rPr>
+              <a:t>Role Rotation — Who Held Each Role, Each Sprint</a:t>
+            </a:r>
+            <a:endParaRPr lang="en-US" sz="2600" dirty="0"/>
+          </a:p>
+        </p:txBody>
+      </p:sp>
+      <p:graphicFrame>
+        <p:nvGraphicFramePr>
+          <p:cNvPr id="6" name="Table 0"/>
+          <p:cNvGraphicFramePr>
+            <a:graphicFrameLocks noGrp="1"/>
+          </p:cNvGraphicFramePr>
+          <p:nvPr>
+            <p:extLst>
+              <p:ext uri="{D42A27DB-BD31-4B8C-83A1-F6EECF244321}">
+                <p14:modId xmlns:p14="http://schemas.microsoft.com/office/powerpoint/2010/main" val="1579011935"/>
+              </p:ext>
+            </p:extLst>
+          </p:nvPr>
+        </p:nvGraphicFramePr>
+        <p:xfrm>
+          <a:off x="548640" y="1554480"/>
+          <a:ext cx="10972800" cy="2350000"/>
+        </p:xfrm>
+        <a:graphic>
+          <a:graphicData uri="http://schemas.openxmlformats.org/drawingml/2006/table">
+            <a:tbl>
+              <a:tblPr/>
+              <a:tblGrid>
+                <a:gridCol w="1500000"/>
+                <a:gridCol w="1578800"/>
+                <a:gridCol w="1578800"/>
+                <a:gridCol w="1578800"/>
+                <a:gridCol w="1578800"/>
+                <a:gridCol w="1578800"/>
+                <a:gridCol w="1578800"/>
+              </a:tblGrid>
+              <a:tr h="520000">
+                <a:tc>
+                  <a:txBody>
+                    <a:bodyPr/>
+                    <a:lstStyle/>
+                    <a:p>
+                      <a:pPr algn="l"/>
+                      <a:r>
+                        <a:rPr b="1" sz="1400">
+                          <a:solidFill>
+                            <a:srgbClr val="FFFFFF"/>
+                          </a:solidFill>
+                        </a:rPr>
+                        <a:t>Sprint</a:t>
+                      </a:r>
+                    </a:p>
+                  </a:txBody>
+                  <a:tcPr marL="91440" marR="91440" marT="45720" marB="45720" anchor="ctr">
+                    <a:lnL w="12700" cap="flat" cmpd="sng" algn="ctr">
+                      <a:solidFill>
+                        <a:srgbClr val="E6EBF3"/>
+                      </a:solidFill>
+                      <a:prstDash val="solid"/>
+                      <a:round/>
+                      <a:headEnd type="none" w="med" len="med"/>
+                      <a:tailEnd type="none" w="med" len="med"/>
+                    </a:lnL>
+                    <a:lnR w="12700" cap="flat" cmpd="sng" algn="ctr">
+                      <a:solidFill>
+                        <a:srgbClr val="E6EBF3"/>
+                      </a:solidFill>
+                      <a:prstDash val="solid"/>
+                      <a:round/>
+                      <a:headEnd type="none" w="med" len="med"/>
+                      <a:tailEnd type="none" w="med" len="med"/>
+                    </a:lnR>
+                    <a:lnT w="12700" cap="flat" cmpd="sng" algn="ctr">
+                      <a:solidFill>
+                        <a:srgbClr val="E6EBF3"/>
+                      </a:solidFill>
+                      <a:prstDash val="solid"/>
+                      <a:round/>
+                      <a:headEnd type="none" w="med" len="med"/>
+                      <a:tailEnd type="none" w="med" len="med"/>
+                    </a:lnT>
+                    <a:lnB w="12700" cap="flat" cmpd="sng" algn="ctr">
+                      <a:solidFill>
+                        <a:srgbClr val="E6EBF3"/>
+                      </a:solidFill>
+                      <a:prstDash val="solid"/>
+                      <a:round/>
+                      <a:headEnd type="none" w="med" len="med"/>
+                      <a:tailEnd type="none" w="med" len="med"/>
+                    </a:lnB>
+                    <a:solidFill>
+                      <a:srgbClr val="0E2A52"/>
+                    </a:solidFill>
+                  </a:tcPr>
+                </a:tc>
+                <a:tc>
+                  <a:txBody>
+                    <a:bodyPr/>
+                    <a:lstStyle/>
+                    <a:p>
+                      <a:pPr algn="l"/>
+                      <a:r>
+                        <a:rPr b="1" sz="1400">
+                          <a:solidFill>
+                            <a:srgbClr val="FFFFFF"/>
+                          </a:solidFill>
+                        </a:rPr>
+                        <a:t>R1</a:t>
+                      </a:r>
+                    </a:p>
+                  </a:txBody>
+                  <a:tcPr marL="91440" marR="91440" marT="45720" marB="45720" anchor="ctr">
+                    <a:lnL w="12700" cap="flat" cmpd="sng" algn="ctr">
+                      <a:solidFill>
+                        <a:srgbClr val="E6EBF3"/>
+                      </a:solidFill>
+                      <a:prstDash val="solid"/>
+                      <a:round/>
+                      <a:headEnd type="none" w="med" len="med"/>
+                      <a:tailEnd type="none" w="med" len="med"/>
+                    </a:lnL>
+                    <a:lnR w="12700" cap="flat" cmpd="sng" algn="ctr">
+                      <a:solidFill>
+                        <a:srgbClr val="E6EBF3"/>
+                      </a:solidFill>
+                      <a:prstDash val="solid"/>
+                      <a:round/>
+                      <a:headEnd type="none" w="med" len="med"/>
+                      <a:tailEnd type="none" w="med" len="med"/>
+                    </a:lnR>
+                    <a:lnT w="12700" cap="flat" cmpd="sng" algn="ctr">
+                      <a:solidFill>
+                        <a:srgbClr val="E6EBF3"/>
+                      </a:solidFill>
+                      <a:prstDash val="solid"/>
+                      <a:round/>
+                      <a:headEnd type="none" w="med" len="med"/>
+                      <a:tailEnd type="none" w="med" len="med"/>
+                    </a:lnT>
+                    <a:lnB w="12700" cap="flat" cmpd="sng" algn="ctr">
+                      <a:solidFill>
+                        <a:srgbClr val="E6EBF3"/>
+                      </a:solidFill>
+                      <a:prstDash val="solid"/>
+                      <a:round/>
+                      <a:headEnd type="none" w="med" len="med"/>
+                      <a:tailEnd type="none" w="med" len="med"/>
+                    </a:lnB>
+                    <a:solidFill>
+                      <a:srgbClr val="0E2A52"/>
+                    </a:solidFill>
+                  </a:tcPr>
+                </a:tc>
+                <a:tc>
+                  <a:txBody>
+                    <a:bodyPr/>
+                    <a:lstStyle/>
+                    <a:p>
+                      <a:pPr algn="l"/>
+                      <a:r>
+                        <a:rPr b="1" sz="1400">
+                          <a:solidFill>
+                            <a:srgbClr val="FFFFFF"/>
+                          </a:solidFill>
+                        </a:rPr>
+                        <a:t>R2</a:t>
+                      </a:r>
+                    </a:p>
+                  </a:txBody>
+                  <a:tcPr marL="91440" marR="91440" marT="45720" marB="45720" anchor="ctr">
+                    <a:lnL w="12700" cap="flat" cmpd="sng" algn="ctr">
+                      <a:solidFill>
+                        <a:srgbClr val="E6EBF3"/>
+                      </a:solidFill>
+                      <a:prstDash val="solid"/>
+                      <a:round/>
+                      <a:headEnd type="none" w="med" len="med"/>
+                      <a:tailEnd type="none" w="med" len="med"/>
+                    </a:lnL>
+                    <a:lnR w="12700" cap="flat" cmpd="sng" algn="ctr">
+                      <a:solidFill>
+                        <a:srgbClr val="E6EBF3"/>
+                      </a:solidFill>
+                      <a:prstDash val="solid"/>
+                      <a:round/>
+                      <a:headEnd type="none" w="med" len="med"/>
+                      <a:tailEnd type="none" w="med" len="med"/>
+                    </a:lnR>
+                    <a:lnT w="12700" cap="flat" cmpd="sng" algn="ctr">
+                      <a:solidFill>
+                        <a:srgbClr val="E6EBF3"/>
+                      </a:solidFill>
+                      <a:prstDash val="solid"/>
+                      <a:round/>
+                      <a:headEnd type="none" w="med" len="med"/>
+                      <a:tailEnd type="none" w="med" len="med"/>
+                    </a:lnT>
+                    <a:lnB w="12700" cap="flat" cmpd="sng" algn="ctr">
+                      <a:solidFill>
+                        <a:srgbClr val="E6EBF3"/>
+                      </a:solidFill>
+                      <a:prstDash val="solid"/>
+                      <a:round/>
+                      <a:headEnd type="none" w="med" len="med"/>
+                      <a:tailEnd type="none" w="med" len="med"/>
+                    </a:lnB>
+                    <a:solidFill>
+                      <a:srgbClr val="0E2A52"/>
+                    </a:solidFill>
+                  </a:tcPr>
+                </a:tc>
+                <a:tc>
+                  <a:txBody>
+                    <a:bodyPr/>
+                    <a:lstStyle/>
+                    <a:p>
+                      <a:pPr algn="l"/>
+                      <a:r>
+                        <a:rPr b="1" sz="1400">
+                          <a:solidFill>
+                            <a:srgbClr val="FFFFFF"/>
+                          </a:solidFill>
+                        </a:rPr>
+                        <a:t>R3</a:t>
+                      </a:r>
+                    </a:p>
+                  </a:txBody>
+                  <a:tcPr marL="91440" marR="91440" marT="45720" marB="45720" anchor="ctr">
+                    <a:lnL w="12700" cap="flat" cmpd="sng" algn="ctr">
+                      <a:solidFill>
+                        <a:srgbClr val="E6EBF3"/>
+                      </a:solidFill>
+                      <a:prstDash val="solid"/>
+                      <a:round/>
+                      <a:headEnd type="none" w="med" len="med"/>
+                      <a:tailEnd type="none" w="med" len="med"/>
+                    </a:lnL>
+                    <a:lnR w="12700" cap="flat" cmpd="sng" algn="ctr">
+                      <a:solidFill>
+                        <a:srgbClr val="E6EBF3"/>
+                      </a:solidFill>
+                      <a:prstDash val="solid"/>
+                      <a:round/>
+                      <a:headEnd type="none" w="med" len="med"/>
+                      <a:tailEnd type="none" w="med" len="med"/>
+                    </a:lnR>
+                    <a:lnT w="12700" cap="flat" cmpd="sng" algn="ctr">
+                      <a:solidFill>
+                        <a:srgbClr val="E6EBF3"/>
+                      </a:solidFill>
+                      <a:prstDash val="solid"/>
+                      <a:round/>
+                      <a:headEnd type="none" w="med" len="med"/>
+                      <a:tailEnd type="none" w="med" len="med"/>
+                    </a:lnT>
+                    <a:lnB w="12700" cap="flat" cmpd="sng" algn="ctr">
+                      <a:solidFill>
+                        <a:srgbClr val="E6EBF3"/>
+                      </a:solidFill>
+                      <a:prstDash val="solid"/>
+                      <a:round/>
+                      <a:headEnd type="none" w="med" len="med"/>
+                      <a:tailEnd type="none" w="med" len="med"/>
+                    </a:lnB>
+                    <a:solidFill>
+                      <a:srgbClr val="0E2A52"/>
+                    </a:solidFill>
+                  </a:tcPr>
+                </a:tc>
+                <a:tc>
+                  <a:txBody>
+                    <a:bodyPr/>
+                    <a:lstStyle/>
+                    <a:p>
+                      <a:pPr algn="l"/>
+                      <a:r>
+                        <a:rPr b="1" sz="1400">
+                          <a:solidFill>
+                            <a:srgbClr val="FFFFFF"/>
+                          </a:solidFill>
+                        </a:rPr>
+                        <a:t>R4</a:t>
+                      </a:r>
+                    </a:p>
+                  </a:txBody>
+                  <a:tcPr marL="91440" marR="91440" marT="45720" marB="45720" anchor="ctr">
+                    <a:lnL w="12700" cap="flat" cmpd="sng" algn="ctr">
+                      <a:solidFill>
+                        <a:srgbClr val="E6EBF3"/>
+                      </a:solidFill>
+                      <a:prstDash val="solid"/>
+                      <a:round/>
+                      <a:headEnd type="none" w="med" len="med"/>
+                      <a:tailEnd type="none" w="med" len="med"/>
+                    </a:lnL>
+                    <a:lnR w="12700" cap="flat" cmpd="sng" algn="ctr">
+                      <a:solidFill>
+                        <a:srgbClr val="E6EBF3"/>
+                      </a:solidFill>
+                      <a:prstDash val="solid"/>
+                      <a:round/>
+                      <a:headEnd type="none" w="med" len="med"/>
+                      <a:tailEnd type="none" w="med" len="med"/>
+                    </a:lnR>
+                    <a:lnT w="12700" cap="flat" cmpd="sng" algn="ctr">
+                      <a:solidFill>
+                        <a:srgbClr val="E6EBF3"/>
+                      </a:solidFill>
+                      <a:prstDash val="solid"/>
+                      <a:round/>
+                      <a:headEnd type="none" w="med" len="med"/>
+                      <a:tailEnd type="none" w="med" len="med"/>
+                    </a:lnT>
+                    <a:lnB w="12700" cap="flat" cmpd="sng" algn="ctr">
+                      <a:solidFill>
+                        <a:srgbClr val="E6EBF3"/>
+                      </a:solidFill>
+                      <a:prstDash val="solid"/>
+                      <a:round/>
+                      <a:headEnd type="none" w="med" len="med"/>
+                      <a:tailEnd type="none" w="med" len="med"/>
+                    </a:lnB>
+                    <a:solidFill>
+                      <a:srgbClr val="0E2A52"/>
+                    </a:solidFill>
+                  </a:tcPr>
+                </a:tc>
+                <a:tc>
+                  <a:txBody>
+                    <a:bodyPr/>
+                    <a:lstStyle/>
+                    <a:p>
+                      <a:pPr algn="l"/>
+                      <a:r>
+                        <a:rPr b="1" sz="1400">
+                          <a:solidFill>
+                            <a:srgbClr val="FFFFFF"/>
+                          </a:solidFill>
+                        </a:rPr>
+                        <a:t>R5</a:t>
+                      </a:r>
+                    </a:p>
+                  </a:txBody>
+                  <a:tcPr marL="91440" marR="91440" marT="45720" marB="45720" anchor="ctr">
+                    <a:lnL w="12700" cap="flat" cmpd="sng" algn="ctr">
+                      <a:solidFill>
+                        <a:srgbClr val="E6EBF3"/>
+                      </a:solidFill>
+                      <a:prstDash val="solid"/>
+                      <a:round/>
+                      <a:headEnd type="none" w="med" len="med"/>
+                      <a:tailEnd type="none" w="med" len="med"/>
+                    </a:lnL>
+                    <a:lnR w="12700" cap="flat" cmpd="sng" algn="ctr">
+                      <a:solidFill>
+                        <a:srgbClr val="E6EBF3"/>
+                      </a:solidFill>
+                      <a:prstDash val="solid"/>
+                      <a:round/>
+                      <a:headEnd type="none" w="med" len="med"/>
+                      <a:tailEnd type="none" w="med" len="med"/>
+                    </a:lnR>
+                    <a:lnT w="12700" cap="flat" cmpd="sng" algn="ctr">
+                      <a:solidFill>
+                        <a:srgbClr val="E6EBF3"/>
+                      </a:solidFill>
+                      <a:prstDash val="solid"/>
+                      <a:round/>
+                      <a:headEnd type="none" w="med" len="med"/>
+                      <a:tailEnd type="none" w="med" len="med"/>
+                    </a:lnT>
+                    <a:lnB w="12700" cap="flat" cmpd="sng" algn="ctr">
+                      <a:solidFill>
+                        <a:srgbClr val="E6EBF3"/>
+                      </a:solidFill>
+                      <a:prstDash val="solid"/>
+                      <a:round/>
+                      <a:headEnd type="none" w="med" len="med"/>
+                      <a:tailEnd type="none" w="med" len="med"/>
+                    </a:lnB>
+                    <a:solidFill>
+                      <a:srgbClr val="0E2A52"/>
+                    </a:solidFill>
+                  </a:tcPr>
+                </a:tc>
+                <a:tc>
+                  <a:txBody>
+                    <a:bodyPr/>
+                    <a:lstStyle/>
+                    <a:p>
+                      <a:pPr algn="l"/>
+                      <a:r>
+                        <a:rPr b="1" sz="1400">
+                          <a:solidFill>
+                            <a:srgbClr val="FFFFFF"/>
+                          </a:solidFill>
+                        </a:rPr>
+                        <a:t>R6</a:t>
+                      </a:r>
+                    </a:p>
+                  </a:txBody>
+                  <a:tcPr marL="91440" marR="91440" marT="45720" marB="45720" anchor="ctr">
+                    <a:lnL w="12700" cap="flat" cmpd="sng" algn="ctr">
+                      <a:solidFill>
+                        <a:srgbClr val="E6EBF3"/>
+                      </a:solidFill>
+                      <a:prstDash val="solid"/>
+                      <a:round/>
+                      <a:headEnd type="none" w="med" len="med"/>
+                      <a:tailEnd type="none" w="med" len="med"/>
+                    </a:lnL>
+                    <a:lnR w="12700" cap="flat" cmpd="sng" algn="ctr">
+                      <a:solidFill>
+                        <a:srgbClr val="E6EBF3"/>
+                      </a:solidFill>
+                      <a:prstDash val="solid"/>
+                      <a:round/>
+                      <a:headEnd type="none" w="med" len="med"/>
+                      <a:tailEnd type="none" w="med" len="med"/>
+                    </a:lnR>
+                    <a:lnT w="12700" cap="flat" cmpd="sng" algn="ctr">
+                      <a:solidFill>
+                        <a:srgbClr val="E6EBF3"/>
+                      </a:solidFill>
+                      <a:prstDash val="solid"/>
+                      <a:round/>
+                      <a:headEnd type="none" w="med" len="med"/>
+                      <a:tailEnd type="none" w="med" len="med"/>
+                    </a:lnT>
+                    <a:lnB w="12700" cap="flat" cmpd="sng" algn="ctr">
+                      <a:solidFill>
+                        <a:srgbClr val="E6EBF3"/>
+                      </a:solidFill>
+                      <a:prstDash val="solid"/>
+                      <a:round/>
+                      <a:headEnd type="none" w="med" len="med"/>
+                      <a:tailEnd type="none" w="med" len="med"/>
+                    </a:lnB>
+                    <a:solidFill>
+                      <a:srgbClr val="0E2A52"/>
+                    </a:solidFill>
+                  </a:tcPr>
+                </a:tc>
+              </a:tr>
+              <a:tr h="610000">
+                <a:tc>
+                  <a:txBody>
+                    <a:bodyPr/>
+                    <a:lstStyle/>
+                    <a:p>
+                      <a:pPr algn="l"/>
+                      <a:r>
+                        <a:rPr sz="1300" b="0">
+                          <a:solidFill>
+                            <a:srgbClr val="102033"/>
+                          </a:solidFill>
+                        </a:rPr>
+                        <a:t>Sprint 2</a:t>
+                      </a:r>
+                    </a:p>
+                  </a:txBody>
+                  <a:tcPr marL="91440" marR="91440" marT="45720" marB="45720">
+                    <a:lnL w="12700" cap="flat" cmpd="sng" algn="ctr">
+                      <a:solidFill>
+                        <a:srgbClr val="E6EBF3"/>
+                      </a:solidFill>
+                      <a:prstDash val="solid"/>
+                      <a:round/>
+                      <a:headEnd type="none" w="med" len="med"/>
+                      <a:tailEnd type="none" w="med" len="med"/>
+                    </a:lnL>
+                    <a:lnR w="12700" cap="flat" cmpd="sng" algn="ctr">
+                      <a:solidFill>
+                        <a:srgbClr val="E6EBF3"/>
+                      </a:solidFill>
+                      <a:prstDash val="solid"/>
+                      <a:round/>
+                      <a:headEnd type="none" w="med" len="med"/>
+                      <a:tailEnd type="none" w="med" len="med"/>
+                    </a:lnR>
+                    <a:lnT w="12700" cap="flat" cmpd="sng" algn="ctr">
+                      <a:solidFill>
+                        <a:srgbClr val="E6EBF3"/>
+                      </a:solidFill>
+                      <a:prstDash val="solid"/>
+                      <a:round/>
+                      <a:headEnd type="none" w="med" len="med"/>
+                      <a:tailEnd type="none" w="med" len="med"/>
+                    </a:lnT>
+                    <a:lnB w="12700" cap="flat" cmpd="sng" algn="ctr">
+                      <a:solidFill>
+                        <a:srgbClr val="E6EBF3"/>
+                      </a:solidFill>
+                      <a:prstDash val="solid"/>
+                      <a:round/>
+                      <a:headEnd type="none" w="med" len="med"/>
+                      <a:tailEnd type="none" w="med" len="med"/>
+                    </a:lnB>
+                    <a:solidFill>
+                      <a:srgbClr val="E3F6F3"/>
+                    </a:solidFill>
+                  </a:tcPr>
+                </a:tc>
+                <a:tc>
+                  <a:txBody>
+                    <a:bodyPr/>
+                    <a:lstStyle/>
+                    <a:p>
+                      <a:pPr algn="l"/>
+                      <a:r>
+                        <a:rPr sz="1300" b="0">
+                          <a:solidFill>
+                            <a:srgbClr val="102033"/>
+                          </a:solidFill>
+                        </a:rPr>
+                        <a:t>Name</a:t>
+                      </a:r>
+                    </a:p>
+                  </a:txBody>
+                  <a:tcPr marL="91440" marR="91440" marT="45720" marB="45720">
+                    <a:lnL w="12700" cap="flat" cmpd="sng" algn="ctr">
+                      <a:solidFill>
+                        <a:srgbClr val="E6EBF3"/>
+                      </a:solidFill>
+                      <a:prstDash val="solid"/>
+                      <a:round/>
+                      <a:headEnd type="none" w="med" len="med"/>
+                      <a:tailEnd type="none" w="med" len="med"/>
+                    </a:lnL>
+                    <a:lnR w="12700" cap="flat" cmpd="sng" algn="ctr">
+                      <a:solidFill>
+                        <a:srgbClr val="E6EBF3"/>
+                      </a:solidFill>
+                      <a:prstDash val="solid"/>
+                      <a:round/>
+                      <a:headEnd type="none" w="med" len="med"/>
+                      <a:tailEnd type="none" w="med" len="med"/>
+                    </a:lnR>
+                    <a:lnT w="12700" cap="flat" cmpd="sng" algn="ctr">
+                      <a:solidFill>
+                        <a:srgbClr val="E6EBF3"/>
+                      </a:solidFill>
+                      <a:prstDash val="solid"/>
+                      <a:round/>
+                      <a:headEnd type="none" w="med" len="med"/>
+                      <a:tailEnd type="none" w="med" len="med"/>
+                    </a:lnT>
+                    <a:lnB w="12700" cap="flat" cmpd="sng" algn="ctr">
+                      <a:solidFill>
+                        <a:srgbClr val="E6EBF3"/>
+                      </a:solidFill>
+                      <a:prstDash val="solid"/>
+                      <a:round/>
+                      <a:headEnd type="none" w="med" len="med"/>
+                      <a:tailEnd type="none" w="med" len="med"/>
+                    </a:lnB>
+                    <a:solidFill>
+                      <a:srgbClr val="E3F6F3"/>
+                    </a:solidFill>
+                  </a:tcPr>
+                </a:tc>
+                <a:tc>
+                  <a:txBody>
+                    <a:bodyPr/>
+                    <a:lstStyle/>
+                    <a:p>
+                      <a:pPr algn="l"/>
+                      <a:r>
+                        <a:rPr sz="1300" b="0">
+                          <a:solidFill>
+                            <a:srgbClr val="102033"/>
+                          </a:solidFill>
+                        </a:rPr>
+                        <a:t>Name</a:t>
+                      </a:r>
+                    </a:p>
+                  </a:txBody>
+                  <a:tcPr marL="91440" marR="91440" marT="45720" marB="45720">
+                    <a:lnL w="12700" cap="flat" cmpd="sng" algn="ctr">
+                      <a:solidFill>
+                        <a:srgbClr val="E6EBF3"/>
+                      </a:solidFill>
+                      <a:prstDash val="solid"/>
+                      <a:round/>
+                      <a:headEnd type="none" w="med" len="med"/>
+                      <a:tailEnd type="none" w="med" len="med"/>
+                    </a:lnL>
+                    <a:lnR w="12700" cap="flat" cmpd="sng" algn="ctr">
+                      <a:solidFill>
+                        <a:srgbClr val="E6EBF3"/>
+                      </a:solidFill>
+                      <a:prstDash val="solid"/>
+                      <a:round/>
+                      <a:headEnd type="none" w="med" len="med"/>
+                      <a:tailEnd type="none" w="med" len="med"/>
+                    </a:lnR>
+                    <a:lnT w="12700" cap="flat" cmpd="sng" algn="ctr">
+                      <a:solidFill>
+                        <a:srgbClr val="E6EBF3"/>
+                      </a:solidFill>
+                      <a:prstDash val="solid"/>
+                      <a:round/>
+                      <a:headEnd type="none" w="med" len="med"/>
+                      <a:tailEnd type="none" w="med" len="med"/>
+                    </a:lnT>
+                    <a:lnB w="12700" cap="flat" cmpd="sng" algn="ctr">
+                      <a:solidFill>
+                        <a:srgbClr val="E6EBF3"/>
+                      </a:solidFill>
+                      <a:prstDash val="solid"/>
+                      <a:round/>
+                      <a:headEnd type="none" w="med" len="med"/>
+                      <a:tailEnd type="none" w="med" len="med"/>
+                    </a:lnB>
+                    <a:solidFill>
+                      <a:srgbClr val="E3F6F3"/>
+                    </a:solidFill>
+                  </a:tcPr>
+                </a:tc>
+                <a:tc>
+                  <a:txBody>
+                    <a:bodyPr/>
+                    <a:lstStyle/>
+                    <a:p>
+                      <a:pPr algn="l"/>
+                      <a:r>
+                        <a:rPr sz="1300" b="0">
+                          <a:solidFill>
+                            <a:srgbClr val="102033"/>
+                          </a:solidFill>
+                        </a:rPr>
+                        <a:t>Name</a:t>
+                      </a:r>
+                    </a:p>
+                  </a:txBody>
+                  <a:tcPr marL="91440" marR="91440" marT="45720" marB="45720">
+                    <a:lnL w="12700" cap="flat" cmpd="sng" algn="ctr">
+                      <a:solidFill>
+                        <a:srgbClr val="E6EBF3"/>
+                      </a:solidFill>
+                      <a:prstDash val="solid"/>
+                      <a:round/>
+                      <a:headEnd type="none" w="med" len="med"/>
+                      <a:tailEnd type="none" w="med" len="med"/>
+                    </a:lnL>
+                    <a:lnR w="12700" cap="flat" cmpd="sng" algn="ctr">
+                      <a:solidFill>
+                        <a:srgbClr val="E6EBF3"/>
+                      </a:solidFill>
+                      <a:prstDash val="solid"/>
+                      <a:round/>
+                      <a:headEnd type="none" w="med" len="med"/>
+                      <a:tailEnd type="none" w="med" len="med"/>
+                    </a:lnR>
+                    <a:lnT w="12700" cap="flat" cmpd="sng" algn="ctr">
+                      <a:solidFill>
+                        <a:srgbClr val="E6EBF3"/>
+                      </a:solidFill>
+                      <a:prstDash val="solid"/>
+                      <a:round/>
+                      <a:headEnd type="none" w="med" len="med"/>
+                      <a:tailEnd type="none" w="med" len="med"/>
+                    </a:lnT>
+                    <a:lnB w="12700" cap="flat" cmpd="sng" algn="ctr">
+                      <a:solidFill>
+                        <a:srgbClr val="E6EBF3"/>
+                      </a:solidFill>
+                      <a:prstDash val="solid"/>
+                      <a:round/>
+                      <a:headEnd type="none" w="med" len="med"/>
+                      <a:tailEnd type="none" w="med" len="med"/>
+                    </a:lnB>
+                    <a:solidFill>
+                      <a:srgbClr val="E3F6F3"/>
+                    </a:solidFill>
+                  </a:tcPr>
+                </a:tc>
+                <a:tc>
+                  <a:txBody>
+                    <a:bodyPr/>
+                    <a:lstStyle/>
+                    <a:p>
+                      <a:pPr algn="l"/>
+                      <a:r>
+                        <a:rPr sz="1300" b="0">
+                          <a:solidFill>
+                            <a:srgbClr val="102033"/>
+                          </a:solidFill>
+                        </a:rPr>
+                        <a:t>Name</a:t>
+                      </a:r>
+                    </a:p>
+                  </a:txBody>
+                  <a:tcPr marL="91440" marR="91440" marT="45720" marB="45720">
+                    <a:lnL w="12700" cap="flat" cmpd="sng" algn="ctr">
+                      <a:solidFill>
+                        <a:srgbClr val="E6EBF3"/>
+                      </a:solidFill>
+                      <a:prstDash val="solid"/>
+                      <a:round/>
+                      <a:headEnd type="none" w="med" len="med"/>
+                      <a:tailEnd type="none" w="med" len="med"/>
+                    </a:lnL>
+                    <a:lnR w="12700" cap="flat" cmpd="sng" algn="ctr">
+                      <a:solidFill>
+                        <a:srgbClr val="E6EBF3"/>
+                      </a:solidFill>
+                      <a:prstDash val="solid"/>
+                      <a:round/>
+                      <a:headEnd type="none" w="med" len="med"/>
+                      <a:tailEnd type="none" w="med" len="med"/>
+                    </a:lnR>
+                    <a:lnT w="12700" cap="flat" cmpd="sng" algn="ctr">
+                      <a:solidFill>
+                        <a:srgbClr val="E6EBF3"/>
+                      </a:solidFill>
+                      <a:prstDash val="solid"/>
+                      <a:round/>
+                      <a:headEnd type="none" w="med" len="med"/>
+                      <a:tailEnd type="none" w="med" len="med"/>
+                    </a:lnT>
+                    <a:lnB w="12700" cap="flat" cmpd="sng" algn="ctr">
+                      <a:solidFill>
+                        <a:srgbClr val="E6EBF3"/>
+                      </a:solidFill>
+                      <a:prstDash val="solid"/>
+                      <a:round/>
+                      <a:headEnd type="none" w="med" len="med"/>
+                      <a:tailEnd type="none" w="med" len="med"/>
+                    </a:lnB>
+                    <a:solidFill>
+                      <a:srgbClr val="E3F6F3"/>
+                    </a:solidFill>
+                  </a:tcPr>
+                </a:tc>
+                <a:tc>
+                  <a:txBody>
+                    <a:bodyPr/>
+                    <a:lstStyle/>
+                    <a:p>
+                      <a:pPr algn="l"/>
+                      <a:r>
+                        <a:rPr sz="1300" b="0">
+                          <a:solidFill>
+                            <a:srgbClr val="102033"/>
+                          </a:solidFill>
+                        </a:rPr>
+                        <a:t>Name</a:t>
+                      </a:r>
+                    </a:p>
+                  </a:txBody>
+                  <a:tcPr marL="91440" marR="91440" marT="45720" marB="45720">
+                    <a:lnL w="12700" cap="flat" cmpd="sng" algn="ctr">
+                      <a:solidFill>
+                        <a:srgbClr val="E6EBF3"/>
+                      </a:solidFill>
+                      <a:prstDash val="solid"/>
+                      <a:round/>
+                      <a:headEnd type="none" w="med" len="med"/>
+                      <a:tailEnd type="none" w="med" len="med"/>
+                    </a:lnL>
+                    <a:lnR w="12700" cap="flat" cmpd="sng" algn="ctr">
+                      <a:solidFill>
+                        <a:srgbClr val="E6EBF3"/>
+                      </a:solidFill>
+                      <a:prstDash val="solid"/>
+                      <a:round/>
+                      <a:headEnd type="none" w="med" len="med"/>
+                      <a:tailEnd type="none" w="med" len="med"/>
+                    </a:lnR>
+                    <a:lnT w="12700" cap="flat" cmpd="sng" algn="ctr">
+                      <a:solidFill>
+                        <a:srgbClr val="E6EBF3"/>
+                      </a:solidFill>
+                      <a:prstDash val="solid"/>
+                      <a:round/>
+                      <a:headEnd type="none" w="med" len="med"/>
+                      <a:tailEnd type="none" w="med" len="med"/>
+                    </a:lnT>
+                    <a:lnB w="12700" cap="flat" cmpd="sng" algn="ctr">
+                      <a:solidFill>
+                        <a:srgbClr val="E6EBF3"/>
+                      </a:solidFill>
+                      <a:prstDash val="solid"/>
+                      <a:round/>
+                      <a:headEnd type="none" w="med" len="med"/>
+                      <a:tailEnd type="none" w="med" len="med"/>
+                    </a:lnB>
+                    <a:solidFill>
+                      <a:srgbClr val="E3F6F3"/>
+                    </a:solidFill>
+                  </a:tcPr>
+                </a:tc>
+                <a:tc>
+                  <a:txBody>
+                    <a:bodyPr/>
+                    <a:lstStyle/>
+                    <a:p>
+                      <a:pPr algn="l"/>
+                      <a:r>
+                        <a:rPr sz="1300" b="0">
+                          <a:solidFill>
+                            <a:srgbClr val="102033"/>
+                          </a:solidFill>
+                        </a:rPr>
+                        <a:t>Name</a:t>
+                      </a:r>
+                    </a:p>
+                  </a:txBody>
+                  <a:tcPr marL="91440" marR="91440" marT="45720" marB="45720">
+                    <a:lnL w="12700" cap="flat" cmpd="sng" algn="ctr">
+                      <a:solidFill>
+                        <a:srgbClr val="E6EBF3"/>
+                      </a:solidFill>
+                      <a:prstDash val="solid"/>
+                      <a:round/>
+                      <a:headEnd type="none" w="med" len="med"/>
+                      <a:tailEnd type="none" w="med" len="med"/>
+                    </a:lnL>
+                    <a:lnR w="12700" cap="flat" cmpd="sng" algn="ctr">
+                      <a:solidFill>
+                        <a:srgbClr val="E6EBF3"/>
+                      </a:solidFill>
+                      <a:prstDash val="solid"/>
+                      <a:round/>
+                      <a:headEnd type="none" w="med" len="med"/>
+                      <a:tailEnd type="none" w="med" len="med"/>
+                    </a:lnR>
+                    <a:lnT w="12700" cap="flat" cmpd="sng" algn="ctr">
+                      <a:solidFill>
+                        <a:srgbClr val="E6EBF3"/>
+                      </a:solidFill>
+                      <a:prstDash val="solid"/>
+                      <a:round/>
+                      <a:headEnd type="none" w="med" len="med"/>
+                      <a:tailEnd type="none" w="med" len="med"/>
+                    </a:lnT>
+                    <a:lnB w="12700" cap="flat" cmpd="sng" algn="ctr">
+                      <a:solidFill>
+                        <a:srgbClr val="E6EBF3"/>
+                      </a:solidFill>
+                      <a:prstDash val="solid"/>
+                      <a:round/>
+                      <a:headEnd type="none" w="med" len="med"/>
+                      <a:tailEnd type="none" w="med" len="med"/>
+                    </a:lnB>
+                    <a:solidFill>
+                      <a:srgbClr val="E3F6F3"/>
+                    </a:solidFill>
+                  </a:tcPr>
+                </a:tc>
+              </a:tr>
+              <a:tr h="610000">
+                <a:tc>
+                  <a:txBody>
+                    <a:bodyPr/>
+                    <a:lstStyle/>
+                    <a:p>
+                      <a:pPr algn="l"/>
+                      <a:r>
+                        <a:rPr sz="1300" b="0">
+                          <a:solidFill>
+                            <a:srgbClr val="102033"/>
+                          </a:solidFill>
+                        </a:rPr>
+                        <a:t>Sprint 3</a:t>
+                      </a:r>
+                    </a:p>
+                  </a:txBody>
+                  <a:tcPr marL="91440" marR="91440" marT="45720" marB="45720">
+                    <a:lnL w="12700" cap="flat" cmpd="sng" algn="ctr">
+                      <a:solidFill>
+                        <a:srgbClr val="E6EBF3"/>
+                      </a:solidFill>
+                      <a:prstDash val="solid"/>
+                      <a:round/>
+                      <a:headEnd type="none" w="med" len="med"/>
+                      <a:tailEnd type="none" w="med" len="med"/>
+                    </a:lnL>
+                    <a:lnR w="12700" cap="flat" cmpd="sng" algn="ctr">
+                      <a:solidFill>
+                        <a:srgbClr val="E6EBF3"/>
+                      </a:solidFill>
+                      <a:prstDash val="solid"/>
+                      <a:round/>
+                      <a:headEnd type="none" w="med" len="med"/>
+                      <a:tailEnd type="none" w="med" len="med"/>
+                    </a:lnR>
+                    <a:lnT w="12700" cap="flat" cmpd="sng" algn="ctr">
+                      <a:solidFill>
+                        <a:srgbClr val="E6EBF3"/>
+                      </a:solidFill>
+                      <a:prstDash val="solid"/>
+                      <a:round/>
+                      <a:headEnd type="none" w="med" len="med"/>
+                      <a:tailEnd type="none" w="med" len="med"/>
+                    </a:lnT>
+                    <a:lnB w="12700" cap="flat" cmpd="sng" algn="ctr">
+                      <a:solidFill>
+                        <a:srgbClr val="E6EBF3"/>
+                      </a:solidFill>
+                      <a:prstDash val="solid"/>
+                      <a:round/>
+                      <a:headEnd type="none" w="med" len="med"/>
+                      <a:tailEnd type="none" w="med" len="med"/>
+                    </a:lnB>
+                    <a:solidFill>
+                      <a:srgbClr val="FFF3DD"/>
+                    </a:solidFill>
+                  </a:tcPr>
+                </a:tc>
+                <a:tc>
+                  <a:txBody>
+                    <a:bodyPr/>
+                    <a:lstStyle/>
+                    <a:p>
+                      <a:pPr algn="l"/>
+                      <a:r>
+                        <a:rPr sz="1300" b="0">
+                          <a:solidFill>
+                            <a:srgbClr val="102033"/>
+                          </a:solidFill>
+                        </a:rPr>
+                        <a:t>Name</a:t>
+                      </a:r>
+                    </a:p>
+                  </a:txBody>
+                  <a:tcPr marL="91440" marR="91440" marT="45720" marB="45720">
+                    <a:lnL w="12700" cap="flat" cmpd="sng" algn="ctr">
+                      <a:solidFill>
+                        <a:srgbClr val="E6EBF3"/>
+                      </a:solidFill>
+                      <a:prstDash val="solid"/>
+                      <a:round/>
+                      <a:headEnd type="none" w="med" len="med"/>
+                      <a:tailEnd type="none" w="med" len="med"/>
+                    </a:lnL>
+                    <a:lnR w="12700" cap="flat" cmpd="sng" algn="ctr">
+                      <a:solidFill>
+                        <a:srgbClr val="E6EBF3"/>
+                      </a:solidFill>
+                      <a:prstDash val="solid"/>
+                      <a:round/>
+                      <a:headEnd type="none" w="med" len="med"/>
+                      <a:tailEnd type="none" w="med" len="med"/>
+                    </a:lnR>
+                    <a:lnT w="12700" cap="flat" cmpd="sng" algn="ctr">
+                      <a:solidFill>
+                        <a:srgbClr val="E6EBF3"/>
+                      </a:solidFill>
+                      <a:prstDash val="solid"/>
+                      <a:round/>
+                      <a:headEnd type="none" w="med" len="med"/>
+                      <a:tailEnd type="none" w="med" len="med"/>
+                    </a:lnT>
+                    <a:lnB w="12700" cap="flat" cmpd="sng" algn="ctr">
+                      <a:solidFill>
+                        <a:srgbClr val="E6EBF3"/>
+                      </a:solidFill>
+                      <a:prstDash val="solid"/>
+                      <a:round/>
+                      <a:headEnd type="none" w="med" len="med"/>
+                      <a:tailEnd type="none" w="med" len="med"/>
+                    </a:lnB>
+                    <a:solidFill>
+                      <a:srgbClr val="FFF3DD"/>
+                    </a:solidFill>
+                  </a:tcPr>
+                </a:tc>
+                <a:tc>
+                  <a:txBody>
+                    <a:bodyPr/>
+                    <a:lstStyle/>
+                    <a:p>
+                      <a:pPr algn="l"/>
+                      <a:r>
+                        <a:rPr sz="1300" b="0">
+                          <a:solidFill>
+                            <a:srgbClr val="102033"/>
+                          </a:solidFill>
+                        </a:rPr>
+                        <a:t>Name</a:t>
+                      </a:r>
+                    </a:p>
+                  </a:txBody>
+                  <a:tcPr marL="91440" marR="91440" marT="45720" marB="45720">
+                    <a:lnL w="12700" cap="flat" cmpd="sng" algn="ctr">
+                      <a:solidFill>
+                        <a:srgbClr val="E6EBF3"/>
+                      </a:solidFill>
+                      <a:prstDash val="solid"/>
+                      <a:round/>
+                      <a:headEnd type="none" w="med" len="med"/>
+                      <a:tailEnd type="none" w="med" len="med"/>
+                    </a:lnL>
+                    <a:lnR w="12700" cap="flat" cmpd="sng" algn="ctr">
+                      <a:solidFill>
+                        <a:srgbClr val="E6EBF3"/>
+                      </a:solidFill>
+                      <a:prstDash val="solid"/>
+                      <a:round/>
+                      <a:headEnd type="none" w="med" len="med"/>
+                      <a:tailEnd type="none" w="med" len="med"/>
+                    </a:lnR>
+                    <a:lnT w="12700" cap="flat" cmpd="sng" algn="ctr">
+                      <a:solidFill>
+                        <a:srgbClr val="E6EBF3"/>
+                      </a:solidFill>
+                      <a:prstDash val="solid"/>
+                      <a:round/>
+                      <a:headEnd type="none" w="med" len="med"/>
+                      <a:tailEnd type="none" w="med" len="med"/>
+                    </a:lnT>
+                    <a:lnB w="12700" cap="flat" cmpd="sng" algn="ctr">
+                      <a:solidFill>
+                        <a:srgbClr val="E6EBF3"/>
+                      </a:solidFill>
+                      <a:prstDash val="solid"/>
+                      <a:round/>
+                      <a:headEnd type="none" w="med" len="med"/>
+                      <a:tailEnd type="none" w="med" len="med"/>
+                    </a:lnB>
+                    <a:solidFill>
+                      <a:srgbClr val="FFF3DD"/>
+                    </a:solidFill>
+                  </a:tcPr>
+                </a:tc>
+                <a:tc>
+                  <a:txBody>
+                    <a:bodyPr/>
+                    <a:lstStyle/>
+                    <a:p>
+                      <a:pPr algn="l"/>
+                      <a:r>
+                        <a:rPr sz="1300" b="0">
+                          <a:solidFill>
+                            <a:srgbClr val="102033"/>
+                          </a:solidFill>
+                        </a:rPr>
+                        <a:t>Name</a:t>
+                      </a:r>
+                    </a:p>
+                  </a:txBody>
+                  <a:tcPr marL="91440" marR="91440" marT="45720" marB="45720">
+                    <a:lnL w="12700" cap="flat" cmpd="sng" algn="ctr">
+                      <a:solidFill>
+                        <a:srgbClr val="E6EBF3"/>
+                      </a:solidFill>
+                      <a:prstDash val="solid"/>
+                      <a:round/>
+                      <a:headEnd type="none" w="med" len="med"/>
+                      <a:tailEnd type="none" w="med" len="med"/>
+                    </a:lnL>
+                    <a:lnR w="12700" cap="flat" cmpd="sng" algn="ctr">
+                      <a:solidFill>
+                        <a:srgbClr val="E6EBF3"/>
+                      </a:solidFill>
+                      <a:prstDash val="solid"/>
+                      <a:round/>
+                      <a:headEnd type="none" w="med" len="med"/>
+                      <a:tailEnd type="none" w="med" len="med"/>
+                    </a:lnR>
+                    <a:lnT w="12700" cap="flat" cmpd="sng" algn="ctr">
+                      <a:solidFill>
+                        <a:srgbClr val="E6EBF3"/>
+                      </a:solidFill>
+                      <a:prstDash val="solid"/>
+                      <a:round/>
+                      <a:headEnd type="none" w="med" len="med"/>
+                      <a:tailEnd type="none" w="med" len="med"/>
+                    </a:lnT>
+                    <a:lnB w="12700" cap="flat" cmpd="sng" algn="ctr">
+                      <a:solidFill>
+                        <a:srgbClr val="E6EBF3"/>
+                      </a:solidFill>
+                      <a:prstDash val="solid"/>
+                      <a:round/>
+                      <a:headEnd type="none" w="med" len="med"/>
+                      <a:tailEnd type="none" w="med" len="med"/>
+                    </a:lnB>
+                    <a:solidFill>
+                      <a:srgbClr val="FFF3DD"/>
+                    </a:solidFill>
+                  </a:tcPr>
+                </a:tc>
+                <a:tc>
+                  <a:txBody>
+                    <a:bodyPr/>
+                    <a:lstStyle/>
+                    <a:p>
+                      <a:pPr algn="l"/>
+                      <a:r>
+                        <a:rPr sz="1300" b="0">
+                          <a:solidFill>
+                            <a:srgbClr val="102033"/>
+                          </a:solidFill>
+                        </a:rPr>
+                        <a:t>Name</a:t>
+                      </a:r>
+                    </a:p>
+                  </a:txBody>
+                  <a:tcPr marL="91440" marR="91440" marT="45720" marB="45720">
+                    <a:lnL w="12700" cap="flat" cmpd="sng" algn="ctr">
+                      <a:solidFill>
+                        <a:srgbClr val="E6EBF3"/>
+                      </a:solidFill>
+                      <a:prstDash val="solid"/>
+                      <a:round/>
+                      <a:headEnd type="none" w="med" len="med"/>
+                      <a:tailEnd type="none" w="med" len="med"/>
+                    </a:lnL>
+                    <a:lnR w="12700" cap="flat" cmpd="sng" algn="ctr">
+                      <a:solidFill>
+                        <a:srgbClr val="E6EBF3"/>
+                      </a:solidFill>
+                      <a:prstDash val="solid"/>
+                      <a:round/>
+                      <a:headEnd type="none" w="med" len="med"/>
+                      <a:tailEnd type="none" w="med" len="med"/>
+                    </a:lnR>
+                    <a:lnT w="12700" cap="flat" cmpd="sng" algn="ctr">
+                      <a:solidFill>
+                        <a:srgbClr val="E6EBF3"/>
+                      </a:solidFill>
+                      <a:prstDash val="solid"/>
+                      <a:round/>
+                      <a:headEnd type="none" w="med" len="med"/>
+                      <a:tailEnd type="none" w="med" len="med"/>
+                    </a:lnT>
+                    <a:lnB w="12700" cap="flat" cmpd="sng" algn="ctr">
+                      <a:solidFill>
+                        <a:srgbClr val="E6EBF3"/>
+                      </a:solidFill>
+                      <a:prstDash val="solid"/>
+                      <a:round/>
+                      <a:headEnd type="none" w="med" len="med"/>
+                      <a:tailEnd type="none" w="med" len="med"/>
+                    </a:lnB>
+                    <a:solidFill>
+                      <a:srgbClr val="FFF3DD"/>
+                    </a:solidFill>
+                  </a:tcPr>
+                </a:tc>
+                <a:tc>
+                  <a:txBody>
+                    <a:bodyPr/>
+                    <a:lstStyle/>
+                    <a:p>
+                      <a:pPr algn="l"/>
+                      <a:r>
+                        <a:rPr sz="1300" b="0">
+                          <a:solidFill>
+                            <a:srgbClr val="102033"/>
+                          </a:solidFill>
+                        </a:rPr>
+                        <a:t>Name</a:t>
+                      </a:r>
+                    </a:p>
+                  </a:txBody>
+                  <a:tcPr marL="91440" marR="91440" marT="45720" marB="45720">
+                    <a:lnL w="12700" cap="flat" cmpd="sng" algn="ctr">
+                      <a:solidFill>
+                        <a:srgbClr val="E6EBF3"/>
+                      </a:solidFill>
+                      <a:prstDash val="solid"/>
+                      <a:round/>
+                      <a:headEnd type="none" w="med" len="med"/>
+                      <a:tailEnd type="none" w="med" len="med"/>
+                    </a:lnL>
+                    <a:lnR w="12700" cap="flat" cmpd="sng" algn="ctr">
+                      <a:solidFill>
+                        <a:srgbClr val="E6EBF3"/>
+                      </a:solidFill>
+                      <a:prstDash val="solid"/>
+                      <a:round/>
+                      <a:headEnd type="none" w="med" len="med"/>
+                      <a:tailEnd type="none" w="med" len="med"/>
+                    </a:lnR>
+                    <a:lnT w="12700" cap="flat" cmpd="sng" algn="ctr">
+                      <a:solidFill>
+                        <a:srgbClr val="E6EBF3"/>
+                      </a:solidFill>
+                      <a:prstDash val="solid"/>
+                      <a:round/>
+                      <a:headEnd type="none" w="med" len="med"/>
+                      <a:tailEnd type="none" w="med" len="med"/>
+                    </a:lnT>
+                    <a:lnB w="12700" cap="flat" cmpd="sng" algn="ctr">
+                      <a:solidFill>
+                        <a:srgbClr val="E6EBF3"/>
+                      </a:solidFill>
+                      <a:prstDash val="solid"/>
+                      <a:round/>
+                      <a:headEnd type="none" w="med" len="med"/>
+                      <a:tailEnd type="none" w="med" len="med"/>
+                    </a:lnB>
+                    <a:solidFill>
+                      <a:srgbClr val="FFF3DD"/>
+                    </a:solidFill>
+                  </a:tcPr>
+                </a:tc>
+                <a:tc>
+                  <a:txBody>
+                    <a:bodyPr/>
+                    <a:lstStyle/>
+                    <a:p>
+                      <a:pPr algn="l"/>
+                      <a:r>
+                        <a:rPr sz="1300" b="0">
+                          <a:solidFill>
+                            <a:srgbClr val="102033"/>
+                          </a:solidFill>
+                        </a:rPr>
+                        <a:t>Name</a:t>
+                      </a:r>
+                    </a:p>
+                  </a:txBody>
+                  <a:tcPr marL="91440" marR="91440" marT="45720" marB="45720">
+                    <a:lnL w="12700" cap="flat" cmpd="sng" algn="ctr">
+                      <a:solidFill>
+                        <a:srgbClr val="E6EBF3"/>
+                      </a:solidFill>
+                      <a:prstDash val="solid"/>
+                      <a:round/>
+                      <a:headEnd type="none" w="med" len="med"/>
+                      <a:tailEnd type="none" w="med" len="med"/>
+                    </a:lnL>
+                    <a:lnR w="12700" cap="flat" cmpd="sng" algn="ctr">
+                      <a:solidFill>
+                        <a:srgbClr val="E6EBF3"/>
+                      </a:solidFill>
+                      <a:prstDash val="solid"/>
+                      <a:round/>
+                      <a:headEnd type="none" w="med" len="med"/>
+                      <a:tailEnd type="none" w="med" len="med"/>
+                    </a:lnR>
+                    <a:lnT w="12700" cap="flat" cmpd="sng" algn="ctr">
+                      <a:solidFill>
+                        <a:srgbClr val="E6EBF3"/>
+                      </a:solidFill>
+                      <a:prstDash val="solid"/>
+                      <a:round/>
+                      <a:headEnd type="none" w="med" len="med"/>
+                      <a:tailEnd type="none" w="med" len="med"/>
+                    </a:lnT>
+                    <a:lnB w="12700" cap="flat" cmpd="sng" algn="ctr">
+                      <a:solidFill>
+                        <a:srgbClr val="E6EBF3"/>
+                      </a:solidFill>
+                      <a:prstDash val="solid"/>
+                      <a:round/>
+                      <a:headEnd type="none" w="med" len="med"/>
+                      <a:tailEnd type="none" w="med" len="med"/>
+                    </a:lnB>
+                    <a:solidFill>
+                      <a:srgbClr val="FFF3DD"/>
+                    </a:solidFill>
+                  </a:tcPr>
+                </a:tc>
+              </a:tr>
+              <a:tr h="610000">
+                <a:tc>
+                  <a:txBody>
+                    <a:bodyPr/>
+                    <a:lstStyle/>
+                    <a:p>
+                      <a:pPr algn="l"/>
+                      <a:r>
+                        <a:rPr sz="1300" b="1">
+                          <a:solidFill>
+                            <a:srgbClr val="102033"/>
+                          </a:solidFill>
+                        </a:rPr>
+                        <a:t>Sprint 4 (current)</a:t>
+                      </a:r>
+                    </a:p>
+                  </a:txBody>
+                  <a:tcPr marL="91440" marR="91440" marT="45720" marB="45720">
+                    <a:lnL w="12700" cap="flat" cmpd="sng" algn="ctr">
+                      <a:solidFill>
+                        <a:srgbClr val="E6EBF3"/>
+                      </a:solidFill>
+                      <a:prstDash val="solid"/>
+                      <a:round/>
+                      <a:headEnd type="none" w="med" len="med"/>
+                      <a:tailEnd type="none" w="med" len="med"/>
+                    </a:lnL>
+                    <a:lnR w="12700" cap="flat" cmpd="sng" algn="ctr">
+                      <a:solidFill>
+                        <a:srgbClr val="E6EBF3"/>
+                      </a:solidFill>
+                      <a:prstDash val="solid"/>
+                      <a:round/>
+                      <a:headEnd type="none" w="med" len="med"/>
+                      <a:tailEnd type="none" w="med" len="med"/>
+                    </a:lnR>
+                    <a:lnT w="12700" cap="flat" cmpd="sng" algn="ctr">
+                      <a:solidFill>
+                        <a:srgbClr val="E6EBF3"/>
+                      </a:solidFill>
+                      <a:prstDash val="solid"/>
+                      <a:round/>
+                      <a:headEnd type="none" w="med" len="med"/>
+                      <a:tailEnd type="none" w="med" len="med"/>
+                    </a:lnT>
+                    <a:lnB w="12700" cap="flat" cmpd="sng" algn="ctr">
+                      <a:solidFill>
+                        <a:srgbClr val="E6EBF3"/>
+                      </a:solidFill>
+                      <a:prstDash val="solid"/>
+                      <a:round/>
+                      <a:headEnd type="none" w="med" len="med"/>
+                      <a:tailEnd type="none" w="med" len="med"/>
+                    </a:lnB>
+                    <a:solidFill>
+                      <a:srgbClr val="FDE6E1"/>
+                    </a:solidFill>
+                  </a:tcPr>
+                </a:tc>
+                <a:tc>
+                  <a:txBody>
+                    <a:bodyPr/>
+                    <a:lstStyle/>
+                    <a:p>
+                      <a:pPr algn="l"/>
+                      <a:r>
+                        <a:rPr sz="1300" b="1">
+                          <a:solidFill>
+                            <a:srgbClr val="102033"/>
+                          </a:solidFill>
+                        </a:rPr>
+                        <a:t>Name</a:t>
+                      </a:r>
+                    </a:p>
+                  </a:txBody>
+                  <a:tcPr marL="91440" marR="91440" marT="45720" marB="45720">
+                    <a:lnL w="12700" cap="flat" cmpd="sng" algn="ctr">
+                      <a:solidFill>
+                        <a:srgbClr val="E6EBF3"/>
+                      </a:solidFill>
+                      <a:prstDash val="solid"/>
+                      <a:round/>
+                      <a:headEnd type="none" w="med" len="med"/>
+                      <a:tailEnd type="none" w="med" len="med"/>
+                    </a:lnL>
+                    <a:lnR w="12700" cap="flat" cmpd="sng" algn="ctr">
+                      <a:solidFill>
+                        <a:srgbClr val="E6EBF3"/>
+                      </a:solidFill>
+                      <a:prstDash val="solid"/>
+                      <a:round/>
+                      <a:headEnd type="none" w="med" len="med"/>
+                      <a:tailEnd type="none" w="med" len="med"/>
+                    </a:lnR>
+                    <a:lnT w="12700" cap="flat" cmpd="sng" algn="ctr">
+                      <a:solidFill>
+                        <a:srgbClr val="E6EBF3"/>
+                      </a:solidFill>
+                      <a:prstDash val="solid"/>
+                      <a:round/>
+                      <a:headEnd type="none" w="med" len="med"/>
+                      <a:tailEnd type="none" w="med" len="med"/>
+                    </a:lnT>
+                    <a:lnB w="12700" cap="flat" cmpd="sng" algn="ctr">
+                      <a:solidFill>
+                        <a:srgbClr val="E6EBF3"/>
+                      </a:solidFill>
+                      <a:prstDash val="solid"/>
+                      <a:round/>
+                      <a:headEnd type="none" w="med" len="med"/>
+                      <a:tailEnd type="none" w="med" len="med"/>
+                    </a:lnB>
+                    <a:solidFill>
+                      <a:srgbClr val="FDE6E1"/>
+                    </a:solidFill>
+                  </a:tcPr>
+                </a:tc>
+                <a:tc>
+                  <a:txBody>
+                    <a:bodyPr/>
+                    <a:lstStyle/>
+                    <a:p>
+                      <a:pPr algn="l"/>
+                      <a:r>
+                        <a:rPr sz="1300" b="1">
+                          <a:solidFill>
+                            <a:srgbClr val="102033"/>
+                          </a:solidFill>
+                        </a:rPr>
+                        <a:t>Name</a:t>
+                      </a:r>
+                    </a:p>
+                  </a:txBody>
+                  <a:tcPr marL="91440" marR="91440" marT="45720" marB="45720">
+                    <a:lnL w="12700" cap="flat" cmpd="sng" algn="ctr">
+                      <a:solidFill>
+                        <a:srgbClr val="E6EBF3"/>
+                      </a:solidFill>
+                      <a:prstDash val="solid"/>
+                      <a:round/>
+                      <a:headEnd type="none" w="med" len="med"/>
+                      <a:tailEnd type="none" w="med" len="med"/>
+                    </a:lnL>
+                    <a:lnR w="12700" cap="flat" cmpd="sng" algn="ctr">
+                      <a:solidFill>
+                        <a:srgbClr val="E6EBF3"/>
+                      </a:solidFill>
+                      <a:prstDash val="solid"/>
+                      <a:round/>
+                      <a:headEnd type="none" w="med" len="med"/>
+                      <a:tailEnd type="none" w="med" len="med"/>
+                    </a:lnR>
+                    <a:lnT w="12700" cap="flat" cmpd="sng" algn="ctr">
+                      <a:solidFill>
+                        <a:srgbClr val="E6EBF3"/>
+                      </a:solidFill>
+                      <a:prstDash val="solid"/>
+                      <a:round/>
+                      <a:headEnd type="none" w="med" len="med"/>
+                      <a:tailEnd type="none" w="med" len="med"/>
+                    </a:lnT>
+                    <a:lnB w="12700" cap="flat" cmpd="sng" algn="ctr">
+                      <a:solidFill>
+                        <a:srgbClr val="E6EBF3"/>
+                      </a:solidFill>
+                      <a:prstDash val="solid"/>
+                      <a:round/>
+                      <a:headEnd type="none" w="med" len="med"/>
+                      <a:tailEnd type="none" w="med" len="med"/>
+                    </a:lnB>
+                    <a:solidFill>
+                      <a:srgbClr val="FDE6E1"/>
+                    </a:solidFill>
+                  </a:tcPr>
+                </a:tc>
+                <a:tc>
+                  <a:txBody>
+                    <a:bodyPr/>
+                    <a:lstStyle/>
+                    <a:p>
+                      <a:pPr algn="l"/>
+                      <a:r>
+                        <a:rPr sz="1300" b="1">
+                          <a:solidFill>
+                            <a:srgbClr val="102033"/>
+                          </a:solidFill>
+                        </a:rPr>
+                        <a:t>Name</a:t>
+                      </a:r>
+                    </a:p>
+                  </a:txBody>
+                  <a:tcPr marL="91440" marR="91440" marT="45720" marB="45720">
+                    <a:lnL w="12700" cap="flat" cmpd="sng" algn="ctr">
+                      <a:solidFill>
+                        <a:srgbClr val="E6EBF3"/>
+                      </a:solidFill>
+                      <a:prstDash val="solid"/>
+                      <a:round/>
+                      <a:headEnd type="none" w="med" len="med"/>
+                      <a:tailEnd type="none" w="med" len="med"/>
+                    </a:lnL>
+                    <a:lnR w="12700" cap="flat" cmpd="sng" algn="ctr">
+                      <a:solidFill>
+                        <a:srgbClr val="E6EBF3"/>
+                      </a:solidFill>
+                      <a:prstDash val="solid"/>
+                      <a:round/>
+                      <a:headEnd type="none" w="med" len="med"/>
+                      <a:tailEnd type="none" w="med" len="med"/>
+                    </a:lnR>
+                    <a:lnT w="12700" cap="flat" cmpd="sng" algn="ctr">
+                      <a:solidFill>
+                        <a:srgbClr val="E6EBF3"/>
+                      </a:solidFill>
+                      <a:prstDash val="solid"/>
+                      <a:round/>
+                      <a:headEnd type="none" w="med" len="med"/>
+                      <a:tailEnd type="none" w="med" len="med"/>
+                    </a:lnT>
+                    <a:lnB w="12700" cap="flat" cmpd="sng" algn="ctr">
+                      <a:solidFill>
+                        <a:srgbClr val="E6EBF3"/>
+                      </a:solidFill>
+                      <a:prstDash val="solid"/>
+                      <a:round/>
+                      <a:headEnd type="none" w="med" len="med"/>
+                      <a:tailEnd type="none" w="med" len="med"/>
+                    </a:lnB>
+                    <a:solidFill>
+                      <a:srgbClr val="FDE6E1"/>
+                    </a:solidFill>
+                  </a:tcPr>
+                </a:tc>
+                <a:tc>
+                  <a:txBody>
+                    <a:bodyPr/>
+                    <a:lstStyle/>
+                    <a:p>
+                      <a:pPr algn="l"/>
+                      <a:r>
+                        <a:rPr sz="1300" b="1">
+                          <a:solidFill>
+                            <a:srgbClr val="102033"/>
+                          </a:solidFill>
+                        </a:rPr>
+                        <a:t>Name</a:t>
+                      </a:r>
+                    </a:p>
+                  </a:txBody>
+                  <a:tcPr marL="91440" marR="91440" marT="45720" marB="45720">
+                    <a:lnL w="12700" cap="flat" cmpd="sng" algn="ctr">
+                      <a:solidFill>
+                        <a:srgbClr val="E6EBF3"/>
+                      </a:solidFill>
+                      <a:prstDash val="solid"/>
+                      <a:round/>
+                      <a:headEnd type="none" w="med" len="med"/>
+                      <a:tailEnd type="none" w="med" len="med"/>
+                    </a:lnL>
+                    <a:lnR w="12700" cap="flat" cmpd="sng" algn="ctr">
+                      <a:solidFill>
+                        <a:srgbClr val="E6EBF3"/>
+                      </a:solidFill>
+                      <a:prstDash val="solid"/>
+                      <a:round/>
+                      <a:headEnd type="none" w="med" len="med"/>
+                      <a:tailEnd type="none" w="med" len="med"/>
+                    </a:lnR>
+                    <a:lnT w="12700" cap="flat" cmpd="sng" algn="ctr">
+                      <a:solidFill>
+                        <a:srgbClr val="E6EBF3"/>
+                      </a:solidFill>
+                      <a:prstDash val="solid"/>
+                      <a:round/>
+                      <a:headEnd type="none" w="med" len="med"/>
+                      <a:tailEnd type="none" w="med" len="med"/>
+                    </a:lnT>
+                    <a:lnB w="12700" cap="flat" cmpd="sng" algn="ctr">
+                      <a:solidFill>
+                        <a:srgbClr val="E6EBF3"/>
+                      </a:solidFill>
+                      <a:prstDash val="solid"/>
+                      <a:round/>
+                      <a:headEnd type="none" w="med" len="med"/>
+                      <a:tailEnd type="none" w="med" len="med"/>
+                    </a:lnB>
+                    <a:solidFill>
+                      <a:srgbClr val="FDE6E1"/>
+                    </a:solidFill>
+                  </a:tcPr>
+                </a:tc>
+                <a:tc>
+                  <a:txBody>
+                    <a:bodyPr/>
+                    <a:lstStyle/>
+                    <a:p>
+                      <a:pPr algn="l"/>
+                      <a:r>
+                        <a:rPr sz="1300" b="1">
+                          <a:solidFill>
+                            <a:srgbClr val="102033"/>
+                          </a:solidFill>
+                        </a:rPr>
+                        <a:t>Name</a:t>
+                      </a:r>
+                    </a:p>
+                  </a:txBody>
+                  <a:tcPr marL="91440" marR="91440" marT="45720" marB="45720">
+                    <a:lnL w="12700" cap="flat" cmpd="sng" algn="ctr">
+                      <a:solidFill>
+                        <a:srgbClr val="E6EBF3"/>
+                      </a:solidFill>
+                      <a:prstDash val="solid"/>
+                      <a:round/>
+                      <a:headEnd type="none" w="med" len="med"/>
+                      <a:tailEnd type="none" w="med" len="med"/>
+                    </a:lnL>
+                    <a:lnR w="12700" cap="flat" cmpd="sng" algn="ctr">
+                      <a:solidFill>
+                        <a:srgbClr val="E6EBF3"/>
+                      </a:solidFill>
+                      <a:prstDash val="solid"/>
+                      <a:round/>
+                      <a:headEnd type="none" w="med" len="med"/>
+                      <a:tailEnd type="none" w="med" len="med"/>
+                    </a:lnR>
+                    <a:lnT w="12700" cap="flat" cmpd="sng" algn="ctr">
+                      <a:solidFill>
+                        <a:srgbClr val="E6EBF3"/>
+                      </a:solidFill>
+                      <a:prstDash val="solid"/>
+                      <a:round/>
+                      <a:headEnd type="none" w="med" len="med"/>
+                      <a:tailEnd type="none" w="med" len="med"/>
+                    </a:lnT>
+                    <a:lnB w="12700" cap="flat" cmpd="sng" algn="ctr">
+                      <a:solidFill>
+                        <a:srgbClr val="E6EBF3"/>
+                      </a:solidFill>
+                      <a:prstDash val="solid"/>
+                      <a:round/>
+                      <a:headEnd type="none" w="med" len="med"/>
+                      <a:tailEnd type="none" w="med" len="med"/>
+                    </a:lnB>
+                    <a:solidFill>
+                      <a:srgbClr val="FDE6E1"/>
+                    </a:solidFill>
+                  </a:tcPr>
+                </a:tc>
+                <a:tc>
+                  <a:txBody>
+                    <a:bodyPr/>
+                    <a:lstStyle/>
+                    <a:p>
+                      <a:pPr algn="l"/>
+                      <a:r>
+                        <a:rPr sz="1300" b="1">
+                          <a:solidFill>
+                            <a:srgbClr val="102033"/>
+                          </a:solidFill>
+                        </a:rPr>
+                        <a:t>Name</a:t>
+                      </a:r>
+                    </a:p>
+                  </a:txBody>
+                  <a:tcPr marL="91440" marR="91440" marT="45720" marB="45720">
+                    <a:lnL w="12700" cap="flat" cmpd="sng" algn="ctr">
+                      <a:solidFill>
+                        <a:srgbClr val="E6EBF3"/>
+                      </a:solidFill>
+                      <a:prstDash val="solid"/>
+                      <a:round/>
+                      <a:headEnd type="none" w="med" len="med"/>
+                      <a:tailEnd type="none" w="med" len="med"/>
+                    </a:lnL>
+                    <a:lnR w="12700" cap="flat" cmpd="sng" algn="ctr">
+                      <a:solidFill>
+                        <a:srgbClr val="E6EBF3"/>
+                      </a:solidFill>
+                      <a:prstDash val="solid"/>
+                      <a:round/>
+                      <a:headEnd type="none" w="med" len="med"/>
+                      <a:tailEnd type="none" w="med" len="med"/>
+                    </a:lnR>
+                    <a:lnT w="12700" cap="flat" cmpd="sng" algn="ctr">
+                      <a:solidFill>
+                        <a:srgbClr val="E6EBF3"/>
+                      </a:solidFill>
+                      <a:prstDash val="solid"/>
+                      <a:round/>
+                      <a:headEnd type="none" w="med" len="med"/>
+                      <a:tailEnd type="none" w="med" len="med"/>
+                    </a:lnT>
+                    <a:lnB w="12700" cap="flat" cmpd="sng" algn="ctr">
+                      <a:solidFill>
+                        <a:srgbClr val="E6EBF3"/>
+                      </a:solidFill>
+                      <a:prstDash val="solid"/>
+                      <a:round/>
+                      <a:headEnd type="none" w="med" len="med"/>
+                      <a:tailEnd type="none" w="med" len="med"/>
+                    </a:lnB>
+                    <a:solidFill>
+                      <a:srgbClr val="FDE6E1"/>
+                    </a:solidFill>
+                  </a:tcPr>
+                </a:tc>
+              </a:tr>
+            </a:tbl>
+          </a:graphicData>
+        </a:graphic>
+      </p:graphicFrame>
+      <p:sp>
+        <p:nvSpPr>
+          <p:cNvPr id="5" name="Text 2"/>
+          <p:cNvSpPr txBox="1"/>
+          <p:nvPr/>
+        </p:nvSpPr>
+        <p:spPr>
+          <a:xfrm>
+            <a:off x="548640" y="4154480"/>
+            <a:ext cx="5486400" cy="274320"/>
+          </a:xfrm>
+          <a:prstGeom prst="rect">
+            <a:avLst/>
+          </a:prstGeom>
+          <a:noFill/>
+          <a:ln/>
+        </p:spPr>
+        <p:txBody>
+          <a:bodyPr wrap="square" rtlCol="0" anchor="ctr"/>
+          <a:lstStyle/>
+          <a:p>
+            <a:pPr indent="0" marL="0">
+              <a:buNone/>
+            </a:pPr>
+            <a:r>
+              <a:rPr lang="en-US" sz="1200" b="1" dirty="0">
+                <a:solidFill>
+                  <a:srgbClr val="0E2A52"/>
+                </a:solidFill>
+                <a:latin typeface="Arial" pitchFamily="34" charset="0"/>
+                <a:ea typeface="Arial" pitchFamily="34" charset="-122"/>
+                <a:cs typeface="Arial" pitchFamily="34" charset="-120"/>
+              </a:rPr>
+              <a:t>HOW TO READ THIS</a:t>
+            </a:r>
+            <a:endParaRPr lang="en-US" sz="1200" dirty="0"/>
+          </a:p>
+        </p:txBody>
+      </p:sp>
+      <p:sp>
+        <p:nvSpPr>
+          <p:cNvPr id="6" name="Text 3"/>
+          <p:cNvSpPr txBox="1"/>
+          <p:nvPr/>
+        </p:nvSpPr>
+        <p:spPr>
+          <a:xfrm>
+            <a:off x="548640" y="4520240"/>
+            <a:ext cx="10972800" cy="914400"/>
+          </a:xfrm>
+          <a:prstGeom prst="rect">
+            <a:avLst/>
+          </a:prstGeom>
+          <a:noFill/>
+          <a:ln/>
+        </p:spPr>
+        <p:txBody>
+          <a:bodyPr wrap="square" rtlCol="0" anchor="ctr"/>
+          <a:lstStyle/>
+          <a:p>
+            <a:pPr indent="0" marL="0">
+              <a:buNone/>
+            </a:pPr>
+            <a:r>
+              <a:rPr lang="en-US" sz="1300" dirty="0">
+                <a:solidFill>
+                  <a:srgbClr val="102033"/>
+                </a:solidFill>
+                <a:latin typeface="Arial" pitchFamily="34" charset="0"/>
+                <a:ea typeface="Arial" pitchFamily="34" charset="-122"/>
+                <a:cs typeface="Arial" pitchFamily="34" charset="-120"/>
+              </a:rPr>
+              <a:t>Each sprint’s row is a different color — teal for Sprint 2, amber for Sprint 3, coral for Sprint 4 (this sprint, in bold) — so the rotation is visible at a glance. R1 (Scrum Master): update this table from data/roles.json before Monday’s presentation. Add a new row at the start of every future sprint — never delete an old one.</a:t>
+            </a:r>
+            <a:endParaRPr lang="en-US" sz="1300" dirty="0"/>
+          </a:p>
+        </p:txBody>
+      </p:sp>
+      <p:sp>
+        <p:nvSpPr>
+          <p:cNvPr id="7" name="Text 4"/>
+          <p:cNvSpPr txBox="1"/>
+          <p:nvPr/>
+        </p:nvSpPr>
+        <p:spPr>
+          <a:xfrm>
+            <a:off x="548640" y="6537960"/>
+            <a:ext cx="7315200" cy="274320"/>
+          </a:xfrm>
+          <a:prstGeom prst="rect">
+            <a:avLst/>
+          </a:prstGeom>
+          <a:noFill/>
+          <a:ln/>
+        </p:spPr>
+        <p:txBody>
+          <a:bodyPr wrap="square" rtlCol="0" anchor="ctr"/>
+          <a:lstStyle/>
+          <a:p>
+            <a:pPr indent="0" marL="0">
+              <a:buNone/>
+            </a:pPr>
+            <a:r>
+              <a:rPr lang="en-US" sz="900" dirty="0">
+                <a:solidFill>
+                  <a:srgbClr val="5A6B80"/>
+                </a:solidFill>
+                <a:latin typeface="Arial" pitchFamily="34" charset="0"/>
+                <a:ea typeface="Arial" pitchFamily="34" charset="-122"/>
+                <a:cs typeface="Arial" pitchFamily="34" charset="-120"/>
+              </a:rPr>
+              <a:t>CP3405 Design Thinking III  ·  TR3 2026</a:t>
+            </a:r>
+            <a:endParaRPr lang="en-US" sz="900" dirty="0"/>
+          </a:p>
+        </p:txBody>
+      </p:sp>
+      <p:sp>
+        <p:nvSpPr>
+          <p:cNvPr id="8" name="Text 5"/>
+          <p:cNvSpPr txBox="1"/>
+          <p:nvPr/>
+        </p:nvSpPr>
+        <p:spPr>
+          <a:xfrm>
+            <a:off x="11612880" y="6537960"/>
+            <a:ext cx="457200" cy="274320"/>
+          </a:xfrm>
+          <a:prstGeom prst="rect">
+            <a:avLst/>
+          </a:prstGeom>
+          <a:noFill/>
+          <a:ln/>
+        </p:spPr>
+        <p:txBody>
+          <a:bodyPr wrap="square" rtlCol="0" anchor="ctr"/>
+          <a:lstStyle/>
+          <a:p>
+            <a:pPr algn="r" indent="0" marL="0">
+              <a:buNone/>
+            </a:pPr>
+            <a:r>
+              <a:rPr lang="en-US" sz="900" dirty="0">
+                <a:solidFill>
+                  <a:srgbClr val="5A6B80"/>
+                </a:solidFill>
+                <a:latin typeface="Arial" pitchFamily="34" charset="0"/>
+                <a:ea typeface="Arial" pitchFamily="34" charset="-122"/>
+                <a:cs typeface="Arial" pitchFamily="34" charset="-120"/>
+              </a:rPr>
+              <a:t>2</a:t>
+            </a:r>
+            <a:endParaRPr lang="en-US" sz="900" dirty="0"/>
+          </a:p>
+        </p:txBody>
+      </p:sp>
+    </p:spTree>
+  </p:cSld>
+  <p:clrMapOvr>
+    <a:masterClrMapping/>
+  </p:clrMapOvr>
+</p:sld>
+</file>
+
+<file path=ppt/slides/slide3.xml><?xml version="1.0" encoding="utf-8"?>
 <p:sld xmlns:a="http://schemas.openxmlformats.org/drawingml/2006/main" xmlns:r="http://schemas.openxmlformats.org/officeDocument/2006/relationships" xmlns:p="http://schemas.openxmlformats.org/presentationml/2006/main">
   <p:cSld name="Slide 2">
     <p:bg>
@@ -2423,7 +4395,7 @@
                 <a:ea typeface="Arial" pitchFamily="34" charset="-122"/>
                 <a:cs typeface="Arial" pitchFamily="34" charset="-120"/>
               </a:rPr>
-              <a:t>2</a:t>
+              <a:t>3</a:t>
             </a:r>
             <a:endParaRPr lang="en-US" sz="900" dirty="0"/>
           </a:p>
@@ -2477,6 +4449,9 @@
               </a:defRPr>
             </a:pPr>
             <a:r>
+              <a:rPr>
+                <a:solidFill/>
+              </a:rPr>
               <a:t>•  [Roles panel: who held each role this sprint — does it match who actually committed?]</a:t>
             </a:r>
           </a:p>
@@ -2510,6 +4485,17 @@
               <a:t>•  [Insert screenshot of your team's actual dashboard here]</a:t>
             </a:r>
           </a:p>
+          <a:p>
+            <a:pPr>
+              <a:spcAft>
+                <a:spcPts val="300"/>
+              </a:spcAft>
+            </a:pPr>
+            <a:r>
+              <a:rPr sz="1100"/>
+              <a:t>•  Did not attend Monday’s presentation: [names, or “none”]</a:t>
+            </a:r>
+          </a:p>
         </p:txBody>
       </p:sp>
     </p:spTree>
@@ -2520,7 +4506,7 @@
 </p:sld>
 </file>
 
-<file path=ppt/slides/slide3.xml><?xml version="1.0" encoding="utf-8"?>
+<file path=ppt/slides/slide4.xml><?xml version="1.0" encoding="utf-8"?>
 <p:sld xmlns:a="http://schemas.openxmlformats.org/drawingml/2006/main" xmlns:r="http://schemas.openxmlformats.org/officeDocument/2006/relationships" xmlns:p="http://schemas.openxmlformats.org/presentationml/2006/main">
   <p:cSld name="Slide 3">
     <p:bg>
@@ -3142,7 +5128,7 @@
                 <a:ea typeface="Arial" pitchFamily="34" charset="-122"/>
                 <a:cs typeface="Arial" pitchFamily="34" charset="-120"/>
               </a:rPr>
-              <a:t>3</a:t>
+              <a:t>4</a:t>
             </a:r>
             <a:endParaRPr lang="en-US" sz="900" dirty="0"/>
           </a:p>
@@ -3156,7 +5142,7 @@
 </p:sld>
 </file>
 
-<file path=ppt/slides/slide4.xml><?xml version="1.0" encoding="utf-8"?>
+<file path=ppt/slides/slide5.xml><?xml version="1.0" encoding="utf-8"?>
 <p:sld xmlns:a="http://schemas.openxmlformats.org/drawingml/2006/main" xmlns:r="http://schemas.openxmlformats.org/officeDocument/2006/relationships" xmlns:p="http://schemas.openxmlformats.org/presentationml/2006/main">
   <p:cSld name="Slide 4">
     <p:bg>
@@ -3712,7 +5698,7 @@
                 <a:ea typeface="Arial" pitchFamily="34" charset="-122"/>
                 <a:cs typeface="Arial" pitchFamily="34" charset="-120"/>
               </a:rPr>
-              <a:t>4</a:t>
+              <a:t>5</a:t>
             </a:r>
             <a:endParaRPr lang="en-US" sz="900" dirty="0"/>
           </a:p>
@@ -3726,7 +5712,7 @@
 </p:sld>
 </file>
 
-<file path=ppt/slides/slide5.xml><?xml version="1.0" encoding="utf-8"?>
+<file path=ppt/slides/slide6.xml><?xml version="1.0" encoding="utf-8"?>
 <p:sld xmlns:a="http://schemas.openxmlformats.org/drawingml/2006/main" xmlns:r="http://schemas.openxmlformats.org/officeDocument/2006/relationships" xmlns:p="http://schemas.openxmlformats.org/presentationml/2006/main">
   <p:cSld name="Slide 5">
     <p:bg>
@@ -4814,7 +6800,7 @@
                 <a:ea typeface="Arial" pitchFamily="34" charset="-122"/>
                 <a:cs typeface="Arial" pitchFamily="34" charset="-120"/>
               </a:rPr>
-              <a:t>5</a:t>
+              <a:t>6</a:t>
             </a:r>
             <a:endParaRPr lang="en-US" sz="900" dirty="0"/>
           </a:p>
@@ -4828,7 +6814,7 @@
 </p:sld>
 </file>
 
-<file path=ppt/slides/slide6.xml><?xml version="1.0" encoding="utf-8"?>
+<file path=ppt/slides/slide7.xml><?xml version="1.0" encoding="utf-8"?>
 <p:sld xmlns:a="http://schemas.openxmlformats.org/drawingml/2006/main" xmlns:r="http://schemas.openxmlformats.org/officeDocument/2006/relationships" xmlns:p="http://schemas.openxmlformats.org/presentationml/2006/main">
   <p:cSld name="Slide 6">
     <p:bg>
@@ -5231,7 +7217,7 @@
                 <a:ea typeface="Arial" pitchFamily="34" charset="-122"/>
                 <a:cs typeface="Arial" pitchFamily="34" charset="-120"/>
               </a:rPr>
-              <a:t>6</a:t>
+              <a:t>7</a:t>
             </a:r>
             <a:endParaRPr lang="en-US" sz="900" dirty="0"/>
           </a:p>
@@ -5245,7 +7231,7 @@
 </p:sld>
 </file>
 
-<file path=ppt/slides/slide7.xml><?xml version="1.0" encoding="utf-8"?>
+<file path=ppt/slides/slide8.xml><?xml version="1.0" encoding="utf-8"?>
 <p:sld xmlns:a="http://schemas.openxmlformats.org/drawingml/2006/main" xmlns:r="http://schemas.openxmlformats.org/officeDocument/2006/relationships" xmlns:p="http://schemas.openxmlformats.org/presentationml/2006/main">
   <p:cSld name="Slide 7">
     <p:bg>
@@ -6242,7 +8228,7 @@
                 <a:ea typeface="Arial" pitchFamily="34" charset="-122"/>
                 <a:cs typeface="Arial" pitchFamily="34" charset="-120"/>
               </a:rPr>
-              <a:t>7</a:t>
+              <a:t>8</a:t>
             </a:r>
             <a:endParaRPr lang="en-US" sz="900" dirty="0"/>
           </a:p>
@@ -6256,7 +8242,7 @@
 </p:sld>
 </file>
 
-<file path=ppt/slides/slide8.xml><?xml version="1.0" encoding="utf-8"?>
+<file path=ppt/slides/slide9.xml><?xml version="1.0" encoding="utf-8"?>
 <p:sld xmlns:a="http://schemas.openxmlformats.org/drawingml/2006/main" xmlns:r="http://schemas.openxmlformats.org/officeDocument/2006/relationships" xmlns:p="http://schemas.openxmlformats.org/presentationml/2006/main">
   <p:cSld name="Slide 8">
     <p:bg>
@@ -6883,7 +8869,7 @@
                 <a:ea typeface="Arial" pitchFamily="34" charset="-122"/>
                 <a:cs typeface="Arial" pitchFamily="34" charset="-120"/>
               </a:rPr>
-              <a:t>8</a:t>
+              <a:t>9</a:t>
             </a:r>
             <a:endParaRPr lang="en-US" sz="900" dirty="0"/>
           </a:p>

</xml_diff>

<commit_message>
Sprint 4 template: recolor the deck's recurring accent from teal to coral throughout, so the sprint is identifiable on every slide (260929_1434)
</commit_message>
<xml_diff>
--- a/assets/sprint4-presentation-template.pptx
+++ b/assets/sprint4-presentation-template.pptx
@@ -1565,7 +1565,7 @@
             <a:r>
               <a:rPr lang="en-US" sz="2000" dirty="0">
                 <a:solidFill>
-                  <a:srgbClr val="12C7B7"/>
+                  <a:srgbClr val="D9694F"/>
                 </a:solidFill>
                 <a:latin typeface="Arial" pitchFamily="34" charset="0"/>
                 <a:ea typeface="Arial" pitchFamily="34" charset="-122"/>
@@ -1680,7 +1680,7 @@
             <a:r>
               <a:rPr sz="2000" b="0">
                 <a:solidFill>
-                  <a:srgbClr val="12C7B7"/>
+                  <a:srgbClr val="D9694F"/>
                 </a:solidFill>
                 <a:latin typeface="Arial"/>
               </a:rPr>
@@ -1748,7 +1748,7 @@
             <a:r>
               <a:rPr lang="en-US" sz="1100" b="1" spc="200" kern="0" dirty="0">
                 <a:solidFill>
-                  <a:srgbClr val="12C7B7"/>
+                  <a:srgbClr val="D9694F"/>
                 </a:solidFill>
                 <a:latin typeface="Arial" pitchFamily="34" charset="0"/>
                 <a:ea typeface="Arial" pitchFamily="34" charset="-122"/>
@@ -3681,7 +3681,7 @@
             <a:r>
               <a:rPr lang="en-US" sz="1100" b="1" spc="200" kern="0" dirty="0">
                 <a:solidFill>
-                  <a:srgbClr val="12C7B7"/>
+                  <a:srgbClr val="D9694F"/>
                 </a:solidFill>
                 <a:latin typeface="Arial" pitchFamily="34" charset="0"/>
                 <a:ea typeface="Arial" pitchFamily="34" charset="-122"/>
@@ -3797,7 +3797,7 @@
             <a:r>
               <a:rPr lang="en-US" sz="1000" b="1" spc="100" kern="0" dirty="0">
                 <a:solidFill>
-                  <a:srgbClr val="12C7B7"/>
+                  <a:srgbClr val="D9694F"/>
                 </a:solidFill>
                 <a:latin typeface="Arial" pitchFamily="34" charset="0"/>
                 <a:ea typeface="Arial" pitchFamily="34" charset="-122"/>
@@ -4429,7 +4429,7 @@
               </a:spcAft>
               <a:defRPr b="1" sz="1100">
                 <a:solidFill>
-                  <a:srgbClr val="12C7B7"/>
+                  <a:srgbClr val="D9694F"/>
                 </a:solidFill>
               </a:defRPr>
             </a:pPr>
@@ -4557,7 +4557,7 @@
             <a:r>
               <a:rPr lang="en-US" sz="1100" b="1" spc="200" kern="0" dirty="0">
                 <a:solidFill>
-                  <a:srgbClr val="12C7B7"/>
+                  <a:srgbClr val="D9694F"/>
                 </a:solidFill>
                 <a:latin typeface="Arial" pitchFamily="34" charset="0"/>
                 <a:ea typeface="Arial" pitchFamily="34" charset="-122"/>
@@ -4826,7 +4826,7 @@
             <a:avLst/>
           </a:prstGeom>
           <a:solidFill>
-            <a:srgbClr val="12C7B7"/>
+            <a:srgbClr val="D9694F"/>
           </a:solidFill>
           <a:ln/>
         </p:spPr>
@@ -5005,7 +5005,7 @@
             <a:r>
               <a:rPr lang="en-US" sz="1100" b="1" spc="100" kern="0" dirty="0">
                 <a:solidFill>
-                  <a:srgbClr val="12C7B7"/>
+                  <a:srgbClr val="D9694F"/>
                 </a:solidFill>
                 <a:latin typeface="Arial" pitchFamily="34" charset="0"/>
                 <a:ea typeface="Arial" pitchFamily="34" charset="-122"/>
@@ -5193,7 +5193,7 @@
             <a:r>
               <a:rPr lang="en-US" sz="1100" b="1" spc="200" kern="0" dirty="0">
                 <a:solidFill>
-                  <a:srgbClr val="12C7B7"/>
+                  <a:srgbClr val="D9694F"/>
                 </a:solidFill>
                 <a:latin typeface="Arial" pitchFamily="34" charset="0"/>
                 <a:ea typeface="Arial" pitchFamily="34" charset="-122"/>
@@ -5341,7 +5341,7 @@
             <a:r>
               <a:rPr lang="en-US" sz="1000" b="1" spc="100" kern="0" dirty="0">
                 <a:solidFill>
-                  <a:srgbClr val="12C7B7"/>
+                  <a:srgbClr val="D9694F"/>
                 </a:solidFill>
                 <a:latin typeface="Arial" pitchFamily="34" charset="0"/>
                 <a:ea typeface="Arial" pitchFamily="34" charset="-122"/>
@@ -5419,7 +5419,7 @@
             <a:r>
               <a:rPr lang="en-US" sz="1000" b="1" spc="100" kern="0" dirty="0">
                 <a:solidFill>
-                  <a:srgbClr val="12C7B7"/>
+                  <a:srgbClr val="D9694F"/>
                 </a:solidFill>
                 <a:latin typeface="Arial" pitchFamily="34" charset="0"/>
                 <a:ea typeface="Arial" pitchFamily="34" charset="-122"/>
@@ -5497,7 +5497,7 @@
             <a:r>
               <a:rPr lang="en-US" sz="1000" b="1" spc="100" kern="0" dirty="0">
                 <a:solidFill>
-                  <a:srgbClr val="12C7B7"/>
+                  <a:srgbClr val="D9694F"/>
                 </a:solidFill>
                 <a:latin typeface="Arial" pitchFamily="34" charset="0"/>
                 <a:ea typeface="Arial" pitchFamily="34" charset="-122"/>
@@ -5575,7 +5575,7 @@
             <a:r>
               <a:rPr lang="en-US" sz="1000" b="1" spc="100" kern="0" dirty="0">
                 <a:solidFill>
-                  <a:srgbClr val="12C7B7"/>
+                  <a:srgbClr val="D9694F"/>
                 </a:solidFill>
                 <a:latin typeface="Arial" pitchFamily="34" charset="0"/>
                 <a:ea typeface="Arial" pitchFamily="34" charset="-122"/>
@@ -5763,7 +5763,7 @@
             <a:r>
               <a:rPr lang="en-US" sz="1100" b="1" spc="200" kern="0" dirty="0">
                 <a:solidFill>
-                  <a:srgbClr val="12C7B7"/>
+                  <a:srgbClr val="D9694F"/>
                 </a:solidFill>
                 <a:latin typeface="Arial" pitchFamily="34" charset="0"/>
                 <a:ea typeface="Arial" pitchFamily="34" charset="-122"/>
@@ -6865,7 +6865,7 @@
             <a:r>
               <a:rPr lang="en-US" sz="1100" b="1" spc="200" kern="0" dirty="0">
                 <a:solidFill>
-                  <a:srgbClr val="12C7B7"/>
+                  <a:srgbClr val="D9694F"/>
                 </a:solidFill>
                 <a:latin typeface="Arial" pitchFamily="34" charset="0"/>
                 <a:ea typeface="Arial" pitchFamily="34" charset="-122"/>
@@ -7078,7 +7078,7 @@
             <a:r>
               <a:rPr lang="en-US" sz="1100" b="1" spc="100" kern="0" dirty="0">
                 <a:solidFill>
-                  <a:srgbClr val="12C7B7"/>
+                  <a:srgbClr val="D9694F"/>
                 </a:solidFill>
                 <a:latin typeface="Arial" pitchFamily="34" charset="0"/>
                 <a:ea typeface="Arial" pitchFamily="34" charset="-122"/>
@@ -7282,7 +7282,7 @@
             <a:r>
               <a:rPr lang="en-US" sz="1100" b="1" spc="200" kern="0" dirty="0">
                 <a:solidFill>
-                  <a:srgbClr val="12C7B7"/>
+                  <a:srgbClr val="D9694F"/>
                 </a:solidFill>
                 <a:latin typeface="Arial" pitchFamily="34" charset="0"/>
                 <a:ea typeface="Arial" pitchFamily="34" charset="-122"/>
@@ -8105,7 +8105,7 @@
             <a:r>
               <a:rPr lang="en-US" sz="1100" b="1" spc="100" kern="0" dirty="0">
                 <a:solidFill>
-                  <a:srgbClr val="12C7B7"/>
+                  <a:srgbClr val="D9694F"/>
                 </a:solidFill>
                 <a:latin typeface="Arial" pitchFamily="34" charset="0"/>
                 <a:ea typeface="Arial" pitchFamily="34" charset="-122"/>
@@ -8293,7 +8293,7 @@
             <a:r>
               <a:rPr lang="en-US" sz="1100" b="1" spc="200" kern="0" dirty="0">
                 <a:solidFill>
-                  <a:srgbClr val="12C7B7"/>
+                  <a:srgbClr val="D9694F"/>
                 </a:solidFill>
                 <a:latin typeface="Arial" pitchFamily="34" charset="0"/>
                 <a:ea typeface="Arial" pitchFamily="34" charset="-122"/>
@@ -8636,7 +8636,7 @@
             <a:avLst/>
           </a:prstGeom>
           <a:solidFill>
-            <a:srgbClr val="12C7B7"/>
+            <a:srgbClr val="D9694F"/>
           </a:solidFill>
           <a:ln/>
         </p:spPr>

</xml_diff>